<commit_message>
Completed Clustering Theory and Lab.
</commit_message>
<xml_diff>
--- a/Lab Programs/Lab Program-Algorithms.pptx
+++ b/Lab Programs/Lab Program-Algorithms.pptx
@@ -764,7 +764,7 @@
           <a:p>
             <a:fld id="{D9B442E5-3501-493E-B556-8D78E402D194}" type="datetimeFigureOut">
               <a:rPr lang="en-IN" smtClean="0"/>
-              <a:t>28-06-2025</a:t>
+              <a:t>06-07-2025</a:t>
             </a:fld>
             <a:endParaRPr lang="en-IN"/>
           </a:p>
@@ -1433,7 +1433,7 @@
           <a:p>
             <a:fld id="{050FF069-687C-4110-9C8F-B52BF36C2535}" type="datetimeFigureOut">
               <a:rPr lang="en-IN" smtClean="0"/>
-              <a:t>28-06-2025</a:t>
+              <a:t>06-07-2025</a:t>
             </a:fld>
             <a:endParaRPr lang="en-IN"/>
           </a:p>
@@ -1631,7 +1631,7 @@
           <a:p>
             <a:fld id="{050FF069-687C-4110-9C8F-B52BF36C2535}" type="datetimeFigureOut">
               <a:rPr lang="en-IN" smtClean="0"/>
-              <a:t>28-06-2025</a:t>
+              <a:t>06-07-2025</a:t>
             </a:fld>
             <a:endParaRPr lang="en-IN"/>
           </a:p>
@@ -1839,7 +1839,7 @@
           <a:p>
             <a:fld id="{050FF069-687C-4110-9C8F-B52BF36C2535}" type="datetimeFigureOut">
               <a:rPr lang="en-IN" smtClean="0"/>
-              <a:t>28-06-2025</a:t>
+              <a:t>06-07-2025</a:t>
             </a:fld>
             <a:endParaRPr lang="en-IN"/>
           </a:p>
@@ -2037,7 +2037,7 @@
           <a:p>
             <a:fld id="{050FF069-687C-4110-9C8F-B52BF36C2535}" type="datetimeFigureOut">
               <a:rPr lang="en-IN" smtClean="0"/>
-              <a:t>28-06-2025</a:t>
+              <a:t>06-07-2025</a:t>
             </a:fld>
             <a:endParaRPr lang="en-IN"/>
           </a:p>
@@ -2313,7 +2313,7 @@
           <a:p>
             <a:fld id="{050FF069-687C-4110-9C8F-B52BF36C2535}" type="datetimeFigureOut">
               <a:rPr lang="en-IN" smtClean="0"/>
-              <a:t>28-06-2025</a:t>
+              <a:t>06-07-2025</a:t>
             </a:fld>
             <a:endParaRPr lang="en-IN"/>
           </a:p>
@@ -2580,7 +2580,7 @@
           <a:p>
             <a:fld id="{050FF069-687C-4110-9C8F-B52BF36C2535}" type="datetimeFigureOut">
               <a:rPr lang="en-IN" smtClean="0"/>
-              <a:t>28-06-2025</a:t>
+              <a:t>06-07-2025</a:t>
             </a:fld>
             <a:endParaRPr lang="en-IN"/>
           </a:p>
@@ -2994,7 +2994,7 @@
           <a:p>
             <a:fld id="{050FF069-687C-4110-9C8F-B52BF36C2535}" type="datetimeFigureOut">
               <a:rPr lang="en-IN" smtClean="0"/>
-              <a:t>28-06-2025</a:t>
+              <a:t>06-07-2025</a:t>
             </a:fld>
             <a:endParaRPr lang="en-IN"/>
           </a:p>
@@ -3141,7 +3141,7 @@
           <a:p>
             <a:fld id="{050FF069-687C-4110-9C8F-B52BF36C2535}" type="datetimeFigureOut">
               <a:rPr lang="en-IN" smtClean="0"/>
-              <a:t>28-06-2025</a:t>
+              <a:t>06-07-2025</a:t>
             </a:fld>
             <a:endParaRPr lang="en-IN"/>
           </a:p>
@@ -3254,7 +3254,7 @@
           <a:p>
             <a:fld id="{050FF069-687C-4110-9C8F-B52BF36C2535}" type="datetimeFigureOut">
               <a:rPr lang="en-IN" smtClean="0"/>
-              <a:t>28-06-2025</a:t>
+              <a:t>06-07-2025</a:t>
             </a:fld>
             <a:endParaRPr lang="en-IN"/>
           </a:p>
@@ -3573,7 +3573,7 @@
           <a:p>
             <a:fld id="{050FF069-687C-4110-9C8F-B52BF36C2535}" type="datetimeFigureOut">
               <a:rPr lang="en-IN" smtClean="0"/>
-              <a:t>28-06-2025</a:t>
+              <a:t>06-07-2025</a:t>
             </a:fld>
             <a:endParaRPr lang="en-IN"/>
           </a:p>
@@ -3868,7 +3868,7 @@
           <a:p>
             <a:fld id="{050FF069-687C-4110-9C8F-B52BF36C2535}" type="datetimeFigureOut">
               <a:rPr lang="en-IN" smtClean="0"/>
-              <a:t>28-06-2025</a:t>
+              <a:t>06-07-2025</a:t>
             </a:fld>
             <a:endParaRPr lang="en-IN"/>
           </a:p>
@@ -5253,7 +5253,7 @@
           <a:p>
             <a:fld id="{050FF069-687C-4110-9C8F-B52BF36C2535}" type="datetimeFigureOut">
               <a:rPr lang="en-IN" smtClean="0"/>
-              <a:t>28-06-2025</a:t>
+              <a:t>06-07-2025</a:t>
             </a:fld>
             <a:endParaRPr lang="en-IN"/>
           </a:p>
@@ -6142,7 +6142,7 @@
               <a:buAutoNum type="arabicPeriod"/>
             </a:pPr>
             <a:r>
-              <a:rPr lang="en-IN" sz="1800" kern="100" dirty="0">
+              <a:rPr lang="en-IN" sz="1800" b="1" kern="100" dirty="0">
                 <a:effectLst/>
                 <a:latin typeface="Aptos" panose="020B0004020202020204" pitchFamily="34" charset="0"/>
                 <a:ea typeface="Aptos" panose="020B0004020202020204" pitchFamily="34" charset="0"/>
@@ -6163,7 +6163,7 @@
               <a:t>k-Means</a:t>
             </a:r>
             <a:r>
-              <a:rPr lang="en-IN" sz="1800" kern="100" dirty="0">
+              <a:rPr lang="en-IN" sz="1800" b="1" kern="100" dirty="0">
                 <a:effectLst/>
                 <a:latin typeface="Aptos" panose="020B0004020202020204" pitchFamily="34" charset="0"/>
                 <a:ea typeface="Aptos" panose="020B0004020202020204" pitchFamily="34" charset="0"/>
@@ -19950,30 +19950,24 @@
             </a:r>
           </a:p>
           <a:p>
+            <a:r>
+              <a:rPr lang="en-US" sz="2400" dirty="0"/>
+              <a:t>X-axis: Experience (Years)</a:t>
+            </a:r>
+          </a:p>
+          <a:p>
             <a:pPr marL="0" indent="0">
               <a:buNone/>
             </a:pPr>
             <a:r>
               <a:rPr lang="en-US" sz="2400" dirty="0"/>
-              <a:t>🔹 X-axis: Experience (Years)</a:t>
-            </a:r>
-          </a:p>
-          <a:p>
-            <a:pPr marL="0" indent="0">
-              <a:buNone/>
-            </a:pPr>
+              <a:t>This is the same input variable as the main graph.</a:t>
+            </a:r>
+          </a:p>
+          <a:p>
             <a:r>
               <a:rPr lang="en-US" sz="2400" dirty="0"/>
-              <a:t>This is the same input variable as the main graph.</a:t>
-            </a:r>
-          </a:p>
-          <a:p>
-            <a:pPr marL="0" indent="0">
-              <a:buNone/>
-            </a:pPr>
-            <a:r>
-              <a:rPr lang="en-US" sz="2400" dirty="0"/>
-              <a:t>🔹 Y-axis: Residuals</a:t>
+              <a:t>Y-axis: Residuals</a:t>
             </a:r>
           </a:p>
           <a:p>
@@ -20048,7 +20042,7 @@
             </a:pPr>
             <a:r>
               <a:rPr lang="en-US" sz="2400" b="1" dirty="0"/>
-              <a:t>2. 🟢 Green Dots</a:t>
+              <a:t>2. Green Dots</a:t>
             </a:r>
           </a:p>
           <a:p>

</xml_diff>

<commit_message>
Completed 2nd Internal Assignment Questions
</commit_message>
<xml_diff>
--- a/Lab Programs/Lab Program-Algorithms.pptx
+++ b/Lab Programs/Lab Program-Algorithms.pptx
@@ -546,18 +546,18 @@
   <pc:docChgLst>
     <pc:chgData name="Pramod Naik" userId="ceb6df04-ef15-4d9b-a141-998a03559d75" providerId="ADAL" clId="{F108514D-1543-4E8C-B71F-048EDEF19F4F}"/>
     <pc:docChg chg="modSld">
-      <pc:chgData name="Pramod Naik" userId="ceb6df04-ef15-4d9b-a141-998a03559d75" providerId="ADAL" clId="{F108514D-1543-4E8C-B71F-048EDEF19F4F}" dt="2025-07-19T12:16:57.043" v="1" actId="207"/>
+      <pc:chgData name="Pramod Naik" userId="ceb6df04-ef15-4d9b-a141-998a03559d75" providerId="ADAL" clId="{F108514D-1543-4E8C-B71F-048EDEF19F4F}" dt="2025-07-19T12:26:02.719" v="3" actId="113"/>
       <pc:docMkLst>
         <pc:docMk/>
       </pc:docMkLst>
       <pc:sldChg chg="modSp mod">
-        <pc:chgData name="Pramod Naik" userId="ceb6df04-ef15-4d9b-a141-998a03559d75" providerId="ADAL" clId="{F108514D-1543-4E8C-B71F-048EDEF19F4F}" dt="2025-07-19T12:16:57.043" v="1" actId="207"/>
+        <pc:chgData name="Pramod Naik" userId="ceb6df04-ef15-4d9b-a141-998a03559d75" providerId="ADAL" clId="{F108514D-1543-4E8C-B71F-048EDEF19F4F}" dt="2025-07-19T12:26:02.719" v="3" actId="113"/>
         <pc:sldMkLst>
           <pc:docMk/>
           <pc:sldMk cId="769431239" sldId="422"/>
         </pc:sldMkLst>
         <pc:spChg chg="mod">
-          <ac:chgData name="Pramod Naik" userId="ceb6df04-ef15-4d9b-a141-998a03559d75" providerId="ADAL" clId="{F108514D-1543-4E8C-B71F-048EDEF19F4F}" dt="2025-07-19T12:16:57.043" v="1" actId="207"/>
+          <ac:chgData name="Pramod Naik" userId="ceb6df04-ef15-4d9b-a141-998a03559d75" providerId="ADAL" clId="{F108514D-1543-4E8C-B71F-048EDEF19F4F}" dt="2025-07-19T12:26:02.719" v="3" actId="113"/>
           <ac:spMkLst>
             <pc:docMk/>
             <pc:sldMk cId="769431239" sldId="422"/>
@@ -5880,7 +5880,7 @@
               <a:buAutoNum type="arabicPeriod"/>
             </a:pPr>
             <a:r>
-              <a:rPr lang="en-IN" sz="1800" kern="100" dirty="0">
+              <a:rPr lang="en-IN" sz="1800" b="1" kern="100" dirty="0">
                 <a:effectLst/>
                 <a:latin typeface="Aptos" panose="020B0004020202020204" pitchFamily="34" charset="0"/>
                 <a:ea typeface="Aptos" panose="020B0004020202020204" pitchFamily="34" charset="0"/>
@@ -6009,7 +6009,7 @@
               <a:buAutoNum type="arabicPeriod"/>
             </a:pPr>
             <a:r>
-              <a:rPr lang="en-IN" sz="1800" kern="100" dirty="0">
+              <a:rPr lang="en-IN" sz="1800" b="1" kern="100" dirty="0">
                 <a:effectLst/>
                 <a:latin typeface="Aptos" panose="020B0004020202020204" pitchFamily="34" charset="0"/>
                 <a:ea typeface="Aptos" panose="020B0004020202020204" pitchFamily="34" charset="0"/>
@@ -6030,7 +6030,7 @@
               <a:t>summary statistics </a:t>
             </a:r>
             <a:r>
-              <a:rPr lang="en-IN" sz="1800" kern="100" dirty="0">
+              <a:rPr lang="en-IN" sz="1800" b="1" kern="100" dirty="0">
                 <a:effectLst/>
                 <a:latin typeface="Aptos" panose="020B0004020202020204" pitchFamily="34" charset="0"/>
                 <a:ea typeface="Aptos" panose="020B0004020202020204" pitchFamily="34" charset="0"/>

</xml_diff>